<commit_message>
Deck demo: two complete-flow walkthroughs (scratch + samples) on slide 8
Replace the single short preview with two longer, captioned walkthroughs shown
side by side:
- 1 · Create from scratch: landing → topic+kinds config → generate → running in
  the background (Generations list) → live process timeline → verified, answer-
  checked questions.
- 2 · Create from samples: multi-select a topic's sample files → configure
  (setup + prompt/rules) → start → background → live process → verified results.
Each is a ~15-17s animated GIF (plays in slideshow); the prior status detail
lines were folded out to give the demos full width.

Co-Authored-By: Claude Opus 4.8 (1M context) <noreply@anthropic.com>
</commit_message>
<xml_diff>
--- a/MCQ_GenAI_Creation_Showcase.pptx
+++ b/MCQ_GenAI_Creation_Showcase.pptx
@@ -19029,511 +19029,123 @@
           </p:txBody>
         </p:sp>
       </p:grpSp>
-      <p:grpSp>
-        <p:nvGrpSpPr>
-          <p:cNvPr name="Group 24" id="24"/>
-          <p:cNvGrpSpPr/>
-          <p:nvPr/>
-        </p:nvGrpSpPr>
-        <p:grpSpPr>
-          <a:xfrm rot="0">
-            <a:off x="987552" y="4416552"/>
-            <a:ext cx="438912" cy="438912"/>
-            <a:chOff x="0" y="0"/>
-            <a:chExt cx="585216" cy="585216"/>
-          </a:xfrm>
-        </p:grpSpPr>
-        <p:sp>
-          <p:nvSpPr>
-            <p:cNvPr name="Freeform 25" id="25" descr="preencoded.png"/>
-            <p:cNvSpPr/>
-            <p:nvPr/>
-          </p:nvSpPr>
-          <p:spPr>
-            <a:xfrm flipH="false" flipV="false" rot="0">
-              <a:off x="0" y="0"/>
-              <a:ext cx="585216" cy="585216"/>
-            </a:xfrm>
-            <a:custGeom>
-              <a:avLst/>
-              <a:gdLst/>
-              <a:ahLst/>
-              <a:cxnLst/>
-              <a:rect r="r" b="b" t="t" l="l"/>
-              <a:pathLst>
-                <a:path h="585216" w="585216">
-                  <a:moveTo>
-                    <a:pt x="0" y="0"/>
-                  </a:moveTo>
-                  <a:lnTo>
-                    <a:pt x="585216" y="0"/>
-                  </a:lnTo>
-                  <a:lnTo>
-                    <a:pt x="585216" y="585216"/>
-                  </a:lnTo>
-                  <a:lnTo>
-                    <a:pt x="0" y="585216"/>
-                  </a:lnTo>
-                  <a:lnTo>
-                    <a:pt x="0" y="0"/>
-                  </a:lnTo>
-                  <a:close/>
-                </a:path>
-              </a:pathLst>
-            </a:custGeom>
-            <a:blipFill>
-              <a:blip r:embed="rId4"/>
-              <a:stretch>
-                <a:fillRect l="0" t="0" r="0" b="0"/>
-              </a:stretch>
-            </a:blipFill>
-          </p:spPr>
-        </p:sp>
-      </p:grpSp>
       <p:sp>
         <p:nvSpPr>
-          <p:cNvPr name="TextBox 26" id="26"/>
-          <p:cNvSpPr txBox="true"/>
+          <p:cNvPr id="24" name="TextBox 23"/>
+          <p:cNvSpPr txBox="1"/>
           <p:nvPr/>
         </p:nvSpPr>
         <p:spPr>
-          <a:xfrm rot="0">
-            <a:off x="1645920" y="4322445"/>
-            <a:ext cx="8366760" cy="1026795"/>
+          <a:xfrm>
+            <a:off x="914400" y="4069080"/>
+            <a:ext cx="7955279" cy="411480"/>
           </a:xfrm>
           <a:prstGeom prst="rect">
             <a:avLst/>
           </a:prstGeom>
+          <a:noFill/>
         </p:spPr>
         <p:txBody>
-          <a:bodyPr anchor="t" rtlCol="false" tIns="0" lIns="0" bIns="0" rIns="0">
+          <a:bodyPr wrap="square">
             <a:spAutoFit/>
           </a:bodyPr>
           <a:lstStyle/>
           <a:p>
-            <a:pPr algn="l">
-              <a:lnSpc>
-                <a:spcPts val="2835"/>
-              </a:lnSpc>
-            </a:pPr>
+            <a:pPr algn="l"/>
             <a:r>
-              <a:rPr lang="en-US" sz="2250">
+              <a:rPr sz="1800" b="1">
                 <a:solidFill>
-                  <a:srgbClr val="333333"/>
+                  <a:srgbClr val="003865"/>
                 </a:solidFill>
-                <a:latin typeface="Calibri (MS)"/>
-                <a:ea typeface="Calibri (MS)"/>
-                <a:cs typeface="Calibri (MS)"/>
-                <a:sym typeface="Calibri (MS)"/>
+                <a:latin typeface="Calibri"/>
               </a:rPr>
-              <a:t>Deployed and running, built on Claude's API.</a:t>
+              <a:t>1 · Create from scratch</a:t>
             </a:r>
           </a:p>
         </p:txBody>
       </p:sp>
-      <p:grpSp>
-        <p:nvGrpSpPr>
-          <p:cNvPr name="Group 27" id="27"/>
-          <p:cNvGrpSpPr/>
-          <p:nvPr/>
-        </p:nvGrpSpPr>
-        <p:grpSpPr>
-          <a:xfrm rot="0">
-            <a:off x="987552" y="5541264"/>
-            <a:ext cx="438912" cy="438912"/>
-            <a:chOff x="0" y="0"/>
-            <a:chExt cx="585216" cy="585216"/>
-          </a:xfrm>
-        </p:grpSpPr>
-        <p:sp>
-          <p:nvSpPr>
-            <p:cNvPr name="Freeform 28" id="28" descr="preencoded.png"/>
-            <p:cNvSpPr/>
-            <p:nvPr/>
-          </p:nvSpPr>
-          <p:spPr>
-            <a:xfrm flipH="false" flipV="false" rot="0">
-              <a:off x="0" y="0"/>
-              <a:ext cx="585216" cy="585216"/>
-            </a:xfrm>
-            <a:custGeom>
-              <a:avLst/>
-              <a:gdLst/>
-              <a:ahLst/>
-              <a:cxnLst/>
-              <a:rect r="r" b="b" t="t" l="l"/>
-              <a:pathLst>
-                <a:path h="585216" w="585216">
-                  <a:moveTo>
-                    <a:pt x="0" y="0"/>
-                  </a:moveTo>
-                  <a:lnTo>
-                    <a:pt x="585216" y="0"/>
-                  </a:lnTo>
-                  <a:lnTo>
-                    <a:pt x="585216" y="585216"/>
-                  </a:lnTo>
-                  <a:lnTo>
-                    <a:pt x="0" y="585216"/>
-                  </a:lnTo>
-                  <a:lnTo>
-                    <a:pt x="0" y="0"/>
-                  </a:lnTo>
-                  <a:close/>
-                </a:path>
-              </a:pathLst>
-            </a:custGeom>
-            <a:blipFill>
-              <a:blip r:embed="rId5"/>
-              <a:stretch>
-                <a:fillRect l="0" t="0" r="0" b="0"/>
-              </a:stretch>
-            </a:blipFill>
-          </p:spPr>
-        </p:sp>
-      </p:grpSp>
-      <p:sp>
-        <p:nvSpPr>
-          <p:cNvPr name="TextBox 29" id="29"/>
-          <p:cNvSpPr txBox="true"/>
-          <p:nvPr/>
-        </p:nvSpPr>
-        <p:spPr>
-          <a:xfrm rot="0">
-            <a:off x="1645920" y="5447157"/>
-            <a:ext cx="8366760" cy="401955"/>
-          </a:xfrm>
-          <a:prstGeom prst="rect">
-            <a:avLst/>
-          </a:prstGeom>
-        </p:spPr>
-        <p:txBody>
-          <a:bodyPr anchor="t" rtlCol="false" tIns="0" lIns="0" bIns="0" rIns="0">
-            <a:spAutoFit/>
-          </a:bodyPr>
-          <a:lstStyle/>
-          <a:p>
-            <a:pPr algn="l">
-              <a:lnSpc>
-                <a:spcPts val="2835"/>
-              </a:lnSpc>
-            </a:pPr>
-            <a:r>
-              <a:rPr lang="en-US" sz="2250">
-                <a:solidFill>
-                  <a:srgbClr val="333333"/>
-                </a:solidFill>
-                <a:latin typeface="Calibri (MS)"/>
-                <a:ea typeface="Calibri (MS)"/>
-                <a:cs typeface="Calibri (MS)"/>
-                <a:sym typeface="Calibri (MS)"/>
-              </a:rPr>
-              <a:t>Available for the team to use testing now.</a:t>
-            </a:r>
-          </a:p>
-        </p:txBody>
-      </p:sp>
-      <p:grpSp>
-        <p:nvGrpSpPr>
-          <p:cNvPr name="Group 30" id="30"/>
-          <p:cNvGrpSpPr/>
-          <p:nvPr/>
-        </p:nvGrpSpPr>
-        <p:grpSpPr>
-          <a:xfrm rot="0">
-            <a:off x="987552" y="6665976"/>
-            <a:ext cx="438912" cy="438912"/>
-            <a:chOff x="0" y="0"/>
-            <a:chExt cx="585216" cy="585216"/>
-          </a:xfrm>
-        </p:grpSpPr>
-        <p:sp>
-          <p:nvSpPr>
-            <p:cNvPr name="Freeform 31" id="31" descr="preencoded.png"/>
-            <p:cNvSpPr/>
-            <p:nvPr/>
-          </p:nvSpPr>
-          <p:spPr>
-            <a:xfrm flipH="false" flipV="false" rot="0">
-              <a:off x="0" y="0"/>
-              <a:ext cx="585216" cy="585216"/>
-            </a:xfrm>
-            <a:custGeom>
-              <a:avLst/>
-              <a:gdLst/>
-              <a:ahLst/>
-              <a:cxnLst/>
-              <a:rect r="r" b="b" t="t" l="l"/>
-              <a:pathLst>
-                <a:path h="585216" w="585216">
-                  <a:moveTo>
-                    <a:pt x="0" y="0"/>
-                  </a:moveTo>
-                  <a:lnTo>
-                    <a:pt x="585216" y="0"/>
-                  </a:lnTo>
-                  <a:lnTo>
-                    <a:pt x="585216" y="585216"/>
-                  </a:lnTo>
-                  <a:lnTo>
-                    <a:pt x="0" y="585216"/>
-                  </a:lnTo>
-                  <a:lnTo>
-                    <a:pt x="0" y="0"/>
-                  </a:lnTo>
-                  <a:close/>
-                </a:path>
-              </a:pathLst>
-            </a:custGeom>
-            <a:blipFill>
-              <a:blip r:embed="rId6"/>
-              <a:stretch>
-                <a:fillRect l="0" t="0" r="0" b="0"/>
-              </a:stretch>
-            </a:blipFill>
-          </p:spPr>
-        </p:sp>
-      </p:grpSp>
-      <p:sp>
-        <p:nvSpPr>
-          <p:cNvPr name="TextBox 32" id="32"/>
-          <p:cNvSpPr txBox="true"/>
-          <p:nvPr/>
-        </p:nvSpPr>
-        <p:spPr>
-          <a:xfrm rot="0">
-            <a:off x="1645920" y="6571869"/>
-            <a:ext cx="8366760" cy="1026795"/>
-          </a:xfrm>
-          <a:prstGeom prst="rect">
-            <a:avLst/>
-          </a:prstGeom>
-        </p:spPr>
-        <p:txBody>
-          <a:bodyPr anchor="t" rtlCol="false" tIns="0" lIns="0" bIns="0" rIns="0">
-            <a:spAutoFit/>
-          </a:bodyPr>
-          <a:lstStyle/>
-          <a:p>
-            <a:pPr algn="l">
-              <a:lnSpc>
-                <a:spcPts val="2835"/>
-              </a:lnSpc>
-            </a:pPr>
-            <a:r>
-              <a:rPr lang="en-US" sz="2250">
-                <a:solidFill>
-                  <a:srgbClr val="333333"/>
-                </a:solidFill>
-                <a:latin typeface="Calibri (MS)"/>
-                <a:ea typeface="Calibri (MS)"/>
-                <a:cs typeface="Calibri (MS)"/>
-                <a:sym typeface="Calibri (MS)"/>
-              </a:rPr>
-              <a:t>Live demo ready — real generations, originality loop on screen.</a:t>
-            </a:r>
-          </a:p>
-        </p:txBody>
-      </p:sp>
-      <p:grpSp>
-        <p:nvGrpSpPr>
-          <p:cNvPr name="Group 33" id="33"/>
-          <p:cNvGrpSpPr/>
-          <p:nvPr/>
-        </p:nvGrpSpPr>
-        <p:grpSpPr>
-          <a:xfrm rot="0">
-            <a:off x="10889932" y="3689033"/>
-            <a:ext cx="6406515" cy="3937635"/>
-            <a:chOff x="0" y="0"/>
-            <a:chExt cx="8542020" cy="5250180"/>
-          </a:xfrm>
-        </p:grpSpPr>
-        <p:sp>
-          <p:nvSpPr>
-            <p:cNvPr name="Freeform 34" id="34"/>
-            <p:cNvSpPr/>
-            <p:nvPr/>
-          </p:nvSpPr>
-          <p:spPr>
-            <a:xfrm flipH="false" flipV="false" rot="0">
-              <a:off x="0" y="0"/>
-              <a:ext cx="8542020" cy="5250180"/>
-            </a:xfrm>
-            <a:custGeom>
-              <a:avLst/>
-              <a:gdLst/>
-              <a:ahLst/>
-              <a:cxnLst/>
-              <a:rect r="r" b="b" t="t" l="l"/>
-              <a:pathLst>
-                <a:path h="5250180" w="8542020">
-                  <a:moveTo>
-                    <a:pt x="0" y="110490"/>
-                  </a:moveTo>
-                  <a:cubicBezTo>
-                    <a:pt x="0" y="49530"/>
-                    <a:pt x="49530" y="0"/>
-                    <a:pt x="110490" y="0"/>
-                  </a:cubicBezTo>
-                  <a:lnTo>
-                    <a:pt x="8431530" y="0"/>
-                  </a:lnTo>
-                  <a:cubicBezTo>
-                    <a:pt x="8492617" y="0"/>
-                    <a:pt x="8542020" y="49530"/>
-                    <a:pt x="8542020" y="110490"/>
-                  </a:cubicBezTo>
-                  <a:lnTo>
-                    <a:pt x="8542020" y="5139690"/>
-                  </a:lnTo>
-                  <a:cubicBezTo>
-                    <a:pt x="8542020" y="5200777"/>
-                    <a:pt x="8492490" y="5250180"/>
-                    <a:pt x="8431530" y="5250180"/>
-                  </a:cubicBezTo>
-                  <a:lnTo>
-                    <a:pt x="110490" y="5250180"/>
-                  </a:lnTo>
-                  <a:cubicBezTo>
-                    <a:pt x="49403" y="5250180"/>
-                    <a:pt x="0" y="5200650"/>
-                    <a:pt x="0" y="5139690"/>
-                  </a:cubicBezTo>
-                  <a:close/>
-                </a:path>
-              </a:pathLst>
-            </a:custGeom>
-            <a:solidFill>
-              <a:srgbClr val="EEF2F7"/>
-            </a:solidFill>
-            <a:ln w="28575" cap="sq">
-              <a:solidFill>
-                <a:srgbClr val="003865"/>
-              </a:solidFill>
-              <a:prstDash val="dash"/>
-              <a:miter/>
-            </a:ln>
-          </p:spPr>
-        </p:sp>
-      </p:grpSp>
-      <p:grpSp>
-        <p:nvGrpSpPr>
-          <p:cNvPr name="Group 35" id="35"/>
-          <p:cNvGrpSpPr/>
-          <p:nvPr/>
-        </p:nvGrpSpPr>
-        <p:grpSpPr>
-          <a:xfrm rot="0">
-            <a:off x="11247120" y="3977640"/>
-            <a:ext cx="2743200" cy="411480"/>
-            <a:chOff x="0" y="0"/>
-            <a:chExt cx="3657600" cy="548640"/>
-          </a:xfrm>
-        </p:grpSpPr>
-        <p:sp>
-          <p:nvSpPr>
-            <p:cNvPr name="Freeform 36" id="36"/>
-            <p:cNvSpPr/>
-            <p:nvPr/>
-          </p:nvSpPr>
-          <p:spPr>
-            <a:xfrm flipH="false" flipV="false" rot="0">
-              <a:off x="0" y="0"/>
-              <a:ext cx="3657600" cy="548640"/>
-            </a:xfrm>
-            <a:custGeom>
-              <a:avLst/>
-              <a:gdLst/>
-              <a:ahLst/>
-              <a:cxnLst/>
-              <a:rect r="r" b="b" t="t" l="l"/>
-              <a:pathLst>
-                <a:path h="548640" w="3657600">
-                  <a:moveTo>
-                    <a:pt x="0" y="0"/>
-                  </a:moveTo>
-                  <a:lnTo>
-                    <a:pt x="3657600" y="0"/>
-                  </a:lnTo>
-                  <a:lnTo>
-                    <a:pt x="3657600" y="548640"/>
-                  </a:lnTo>
-                  <a:lnTo>
-                    <a:pt x="0" y="548640"/>
-                  </a:lnTo>
-                  <a:close/>
-                </a:path>
-              </a:pathLst>
-            </a:custGeom>
-            <a:blipFill>
-              <a:blip r:embed="rId3">
-                <a:alphaModFix amt="0"/>
-              </a:blip>
-              <a:stretch>
-                <a:fillRect l="0" t="-79900" r="0" b="-79900"/>
-              </a:stretch>
-            </a:blipFill>
-          </p:spPr>
-        </p:sp>
-        <p:sp>
-          <p:nvSpPr>
-            <p:cNvPr name="TextBox 37" id="37"/>
-            <p:cNvSpPr txBox="true"/>
-            <p:nvPr/>
-          </p:nvSpPr>
-          <p:spPr>
-            <a:xfrm>
-              <a:off x="0" y="-28575"/>
-              <a:ext cx="3657600" cy="577215"/>
-            </a:xfrm>
-            <a:prstGeom prst="rect">
-              <a:avLst/>
-            </a:prstGeom>
-          </p:spPr>
-          <p:txBody>
-            <a:bodyPr anchor="ctr" rtlCol="false" tIns="0" lIns="0" bIns="0" rIns="0"/>
-            <a:lstStyle/>
-            <a:p>
-              <a:pPr algn="l">
-                <a:lnSpc>
-                  <a:spcPts val="1980"/>
-                </a:lnSpc>
-              </a:pPr>
-              <a:r>
-                <a:rPr lang="en-US" b="true" sz="1650" spc="450">
-                  <a:solidFill>
-                    <a:srgbClr val="5E8C1E"/>
-                  </a:solidFill>
-                  <a:latin typeface="Calibri (MS) Bold"/>
-                  <a:ea typeface="Calibri (MS) Bold"/>
-                  <a:cs typeface="Calibri (MS) Bold"/>
-                  <a:sym typeface="Calibri (MS) Bold"/>
-                </a:rPr>
-                <a:t>DEMO</a:t>
-              </a:r>
-            </a:p>
-          </p:txBody>
-        </p:sp>
-      </p:grpSp>
       <p:pic>
         <p:nvPicPr>
-          <p:cNvPr id="38" name="Picture 37" descr="walkthrough.gif"/>
+          <p:cNvPr id="25" name="Picture 24" descr="scratch_flow.gif"/>
           <p:cNvPicPr>
             <a:picLocks noChangeAspect="1"/>
           </p:cNvPicPr>
           <p:nvPr/>
         </p:nvPicPr>
         <p:blipFill>
-          <a:blip r:embed="rId8"/>
+          <a:blip r:embed="rId9"/>
           <a:stretch>
             <a:fillRect/>
           </a:stretch>
         </p:blipFill>
         <p:spPr>
           <a:xfrm>
-            <a:off x="11027664" y="4526280"/>
-            <a:ext cx="6135624" cy="2880360"/>
+            <a:off x="914400" y="4572000"/>
+            <a:ext cx="7955279" cy="3730752"/>
+          </a:xfrm>
+          <a:prstGeom prst="rect">
+            <a:avLst/>
+          </a:prstGeom>
+          <a:ln w="12700">
+            <a:solidFill>
+              <a:srgbClr val="D3D8E0"/>
+            </a:solidFill>
+          </a:ln>
+        </p:spPr>
+      </p:pic>
+      <p:sp>
+        <p:nvSpPr>
+          <p:cNvPr id="26" name="TextBox 25"/>
+          <p:cNvSpPr txBox="1"/>
+          <p:nvPr/>
+        </p:nvSpPr>
+        <p:spPr>
+          <a:xfrm>
+            <a:off x="9418320" y="4069080"/>
+            <a:ext cx="7955279" cy="411480"/>
+          </a:xfrm>
+          <a:prstGeom prst="rect">
+            <a:avLst/>
+          </a:prstGeom>
+          <a:noFill/>
+        </p:spPr>
+        <p:txBody>
+          <a:bodyPr wrap="square">
+            <a:spAutoFit/>
+          </a:bodyPr>
+          <a:lstStyle/>
+          <a:p>
+            <a:pPr algn="l"/>
+            <a:r>
+              <a:rPr sz="1800" b="1">
+                <a:solidFill>
+                  <a:srgbClr val="003865"/>
+                </a:solidFill>
+                <a:latin typeface="Calibri"/>
+              </a:rPr>
+              <a:t>2 · Create from samples</a:t>
+            </a:r>
+          </a:p>
+        </p:txBody>
+      </p:sp>
+      <p:pic>
+        <p:nvPicPr>
+          <p:cNvPr id="27" name="Picture 26" descr="samples_flow.gif"/>
+          <p:cNvPicPr>
+            <a:picLocks noChangeAspect="1"/>
+          </p:cNvPicPr>
+          <p:nvPr/>
+        </p:nvPicPr>
+        <p:blipFill>
+          <a:blip r:embed="rId10"/>
+          <a:stretch>
+            <a:fillRect/>
+          </a:stretch>
+        </p:blipFill>
+        <p:spPr>
+          <a:xfrm>
+            <a:off x="9418320" y="4572000"/>
+            <a:ext cx="7955279" cy="3730752"/>
           </a:xfrm>
           <a:prstGeom prst="rect">
             <a:avLst/>

</xml_diff>